<commit_message>
Rebrand slide to Thre360 Energy colours
Updated build script and output with Thre360 Energy brand colours (blue header,
green/orange accents) replacing Strateq branding.

https://claude.ai/code/session_01UeukPdaSjDsnWVxrjEZNDp
</commit_message>
<xml_diff>
--- a/Operations_Digital_Delivery_June2026.pptx
+++ b/Operations_Digital_Delivery_June2026.pptx
@@ -3103,9 +3103,9 @@
             <a:avLst/>
           </a:prstGeom>
           <a:solidFill>
-            <a:srgbClr val="F4F6F9"/>
+            <a:srgbClr val="F3F7FB"/>
           </a:solidFill>
-          <a:ln w="9525">
+          <a:ln w="6350">
             <a:noFill/>
           </a:ln>
         </p:spPr>
@@ -3140,15 +3140,15 @@
         <p:spPr>
           <a:xfrm>
             <a:off x="0" y="0"/>
-            <a:ext cx="12188952" cy="621792"/>
+            <a:ext cx="12188952" cy="658368"/>
           </a:xfrm>
           <a:prstGeom prst="rect">
             <a:avLst/>
           </a:prstGeom>
           <a:solidFill>
-            <a:srgbClr val="1A375E"/>
+            <a:srgbClr val="1A65AC"/>
           </a:solidFill>
-          <a:ln w="9525">
+          <a:ln w="6350">
             <a:noFill/>
           </a:ln>
         </p:spPr>
@@ -3182,16 +3182,16 @@
         </p:nvSpPr>
         <p:spPr>
           <a:xfrm>
-            <a:off x="0" y="621792"/>
-            <a:ext cx="12188952" cy="38100"/>
+            <a:off x="0" y="658368"/>
+            <a:ext cx="12188952" cy="50800"/>
           </a:xfrm>
           <a:prstGeom prst="rect">
             <a:avLst/>
           </a:prstGeom>
           <a:solidFill>
-            <a:srgbClr val="F08C00"/>
+            <a:srgbClr val="3A9935"/>
           </a:solidFill>
-          <a:ln w="9525">
+          <a:ln w="6350">
             <a:noFill/>
           </a:ln>
         </p:spPr>
@@ -3219,57 +3219,22 @@
       </p:sp>
       <p:sp>
         <p:nvSpPr>
-          <p:cNvPr id="5" name="TextBox 4"/>
-          <p:cNvSpPr txBox="1"/>
-          <p:nvPr/>
-        </p:nvSpPr>
-        <p:spPr>
-          <a:xfrm>
-            <a:off x="274320" y="109728"/>
-            <a:ext cx="11640312" cy="420624"/>
-          </a:xfrm>
-          <a:prstGeom prst="rect">
-            <a:avLst/>
-          </a:prstGeom>
-          <a:noFill/>
-        </p:spPr>
-        <p:txBody>
-          <a:bodyPr wrap="square">
-            <a:spAutoFit/>
-          </a:bodyPr>
-          <a:lstStyle/>
-          <a:p>
-            <a:pPr algn="l"/>
-            <a:r>
-              <a:rPr sz="2200" b="1" i="0">
-                <a:solidFill>
-                  <a:srgbClr val="FFFFFF"/>
-                </a:solidFill>
-                <a:latin typeface="Calibri"/>
-              </a:rPr>
-              <a:t>Operations Digital Delivery  –  June 2026</a:t>
-            </a:r>
-          </a:p>
-        </p:txBody>
-      </p:sp>
-      <p:sp>
-        <p:nvSpPr>
-          <p:cNvPr id="6" name="Rectangle 5"/>
+          <p:cNvPr id="5" name="Rectangle 4"/>
           <p:cNvSpPr/>
           <p:nvPr/>
         </p:nvSpPr>
         <p:spPr>
           <a:xfrm>
-            <a:off x="274320" y="822960"/>
-            <a:ext cx="2786634" cy="914400"/>
+            <a:off x="0" y="709168"/>
+            <a:ext cx="12188952" cy="25400"/>
           </a:xfrm>
           <a:prstGeom prst="rect">
             <a:avLst/>
           </a:prstGeom>
           <a:solidFill>
-            <a:srgbClr val="1A375E"/>
+            <a:srgbClr val="E8821A"/>
           </a:solidFill>
-          <a:ln w="9525">
+          <a:ln w="6350">
             <a:noFill/>
           </a:ln>
         </p:spPr>
@@ -3297,22 +3262,92 @@
       </p:sp>
       <p:sp>
         <p:nvSpPr>
-          <p:cNvPr id="7" name="Rectangle 6"/>
+          <p:cNvPr id="6" name="TextBox 5"/>
+          <p:cNvSpPr txBox="1"/>
+          <p:nvPr/>
+        </p:nvSpPr>
+        <p:spPr>
+          <a:xfrm>
+            <a:off x="292608" y="118872"/>
+            <a:ext cx="8229600" cy="457200"/>
+          </a:xfrm>
+          <a:prstGeom prst="rect">
+            <a:avLst/>
+          </a:prstGeom>
+          <a:noFill/>
+        </p:spPr>
+        <p:txBody>
+          <a:bodyPr wrap="square">
+            <a:spAutoFit/>
+          </a:bodyPr>
+          <a:lstStyle/>
+          <a:p>
+            <a:pPr algn="l"/>
+            <a:r>
+              <a:rPr sz="2200" b="1" i="0">
+                <a:solidFill>
+                  <a:srgbClr val="FFFFFF"/>
+                </a:solidFill>
+                <a:latin typeface="Calibri"/>
+              </a:rPr>
+              <a:t>Operations Digital Delivery  –  June 2026</a:t>
+            </a:r>
+          </a:p>
+        </p:txBody>
+      </p:sp>
+      <p:sp>
+        <p:nvSpPr>
+          <p:cNvPr id="7" name="TextBox 6"/>
+          <p:cNvSpPr txBox="1"/>
+          <p:nvPr/>
+        </p:nvSpPr>
+        <p:spPr>
+          <a:xfrm>
+            <a:off x="9994392" y="146304"/>
+            <a:ext cx="2011680" cy="384048"/>
+          </a:xfrm>
+          <a:prstGeom prst="rect">
+            <a:avLst/>
+          </a:prstGeom>
+          <a:noFill/>
+        </p:spPr>
+        <p:txBody>
+          <a:bodyPr wrap="square">
+            <a:spAutoFit/>
+          </a:bodyPr>
+          <a:lstStyle/>
+          <a:p>
+            <a:pPr algn="r"/>
+            <a:r>
+              <a:rPr sz="1300" b="1" i="0">
+                <a:solidFill>
+                  <a:srgbClr val="FFFFFF"/>
+                </a:solidFill>
+                <a:latin typeface="Calibri"/>
+              </a:rPr>
+              <a:t>THRE360  ENERGY</a:t>
+            </a:r>
+          </a:p>
+        </p:txBody>
+      </p:sp>
+      <p:sp>
+        <p:nvSpPr>
+          <p:cNvPr id="8" name="Rectangle 7"/>
           <p:cNvSpPr/>
           <p:nvPr/>
         </p:nvSpPr>
         <p:spPr>
           <a:xfrm>
-            <a:off x="274320" y="822960"/>
-            <a:ext cx="2786634" cy="50800"/>
+            <a:off x="292608" y="859536"/>
+            <a:ext cx="2777490" cy="877824"/>
           </a:xfrm>
           <a:prstGeom prst="rect">
             <a:avLst/>
           </a:prstGeom>
           <a:solidFill>
-            <a:srgbClr val="F08C00"/>
+            <a:srgbClr val="1A65AC"/>
           </a:solidFill>
-          <a:ln w="9525">
+          <a:ln w="6350">
             <a:noFill/>
           </a:ln>
         </p:spPr>
@@ -3340,92 +3375,22 @@
       </p:sp>
       <p:sp>
         <p:nvSpPr>
-          <p:cNvPr id="8" name="TextBox 7"/>
-          <p:cNvSpPr txBox="1"/>
-          <p:nvPr/>
-        </p:nvSpPr>
-        <p:spPr>
-          <a:xfrm>
-            <a:off x="365760" y="877824"/>
-            <a:ext cx="2603754" cy="384048"/>
-          </a:xfrm>
-          <a:prstGeom prst="rect">
-            <a:avLst/>
-          </a:prstGeom>
-          <a:noFill/>
-        </p:spPr>
-        <p:txBody>
-          <a:bodyPr wrap="square">
-            <a:spAutoFit/>
-          </a:bodyPr>
-          <a:lstStyle/>
-          <a:p>
-            <a:pPr algn="ctr"/>
-            <a:r>
-              <a:rPr sz="1250" b="1" i="0">
-                <a:solidFill>
-                  <a:srgbClr val="FFFFFF"/>
-                </a:solidFill>
-                <a:latin typeface="Calibri"/>
-              </a:rPr>
-              <a:t>Under Budget</a:t>
-            </a:r>
-          </a:p>
-        </p:txBody>
-      </p:sp>
-      <p:sp>
-        <p:nvSpPr>
-          <p:cNvPr id="9" name="TextBox 8"/>
-          <p:cNvSpPr txBox="1"/>
-          <p:nvPr/>
-        </p:nvSpPr>
-        <p:spPr>
-          <a:xfrm>
-            <a:off x="347472" y="1243584"/>
-            <a:ext cx="2640330" cy="384048"/>
-          </a:xfrm>
-          <a:prstGeom prst="rect">
-            <a:avLst/>
-          </a:prstGeom>
-          <a:noFill/>
-        </p:spPr>
-        <p:txBody>
-          <a:bodyPr wrap="square">
-            <a:spAutoFit/>
-          </a:bodyPr>
-          <a:lstStyle/>
-          <a:p>
-            <a:pPr algn="ctr"/>
-            <a:r>
-              <a:rPr sz="850" b="0" i="0">
-                <a:solidFill>
-                  <a:srgbClr val="D0D8E4"/>
-                </a:solidFill>
-                <a:latin typeface="Calibri"/>
-              </a:rPr>
-              <a:t>All initiatives</a:t>
-            </a:r>
-          </a:p>
-        </p:txBody>
-      </p:sp>
-      <p:sp>
-        <p:nvSpPr>
-          <p:cNvPr id="10" name="Rectangle 9"/>
+          <p:cNvPr id="9" name="Rectangle 8"/>
           <p:cNvSpPr/>
           <p:nvPr/>
         </p:nvSpPr>
         <p:spPr>
           <a:xfrm>
-            <a:off x="3225546" y="822960"/>
-            <a:ext cx="2786634" cy="914400"/>
+            <a:off x="292608" y="859536"/>
+            <a:ext cx="2777490" cy="63500"/>
           </a:xfrm>
           <a:prstGeom prst="rect">
             <a:avLst/>
           </a:prstGeom>
           <a:solidFill>
-            <a:srgbClr val="1A375E"/>
+            <a:srgbClr val="3A9935"/>
           </a:solidFill>
-          <a:ln w="9525">
+          <a:ln w="6350">
             <a:noFill/>
           </a:ln>
         </p:spPr>
@@ -3453,22 +3418,92 @@
       </p:sp>
       <p:sp>
         <p:nvSpPr>
-          <p:cNvPr id="11" name="Rectangle 10"/>
+          <p:cNvPr id="10" name="TextBox 9"/>
+          <p:cNvSpPr txBox="1"/>
+          <p:nvPr/>
+        </p:nvSpPr>
+        <p:spPr>
+          <a:xfrm>
+            <a:off x="384048" y="923544"/>
+            <a:ext cx="2594610" cy="384048"/>
+          </a:xfrm>
+          <a:prstGeom prst="rect">
+            <a:avLst/>
+          </a:prstGeom>
+          <a:noFill/>
+        </p:spPr>
+        <p:txBody>
+          <a:bodyPr wrap="square">
+            <a:spAutoFit/>
+          </a:bodyPr>
+          <a:lstStyle/>
+          <a:p>
+            <a:pPr algn="ctr"/>
+            <a:r>
+              <a:rPr sz="1200" b="1" i="0">
+                <a:solidFill>
+                  <a:srgbClr val="FFFFFF"/>
+                </a:solidFill>
+                <a:latin typeface="Calibri"/>
+              </a:rPr>
+              <a:t>Under Budget</a:t>
+            </a:r>
+          </a:p>
+        </p:txBody>
+      </p:sp>
+      <p:sp>
+        <p:nvSpPr>
+          <p:cNvPr id="11" name="TextBox 10"/>
+          <p:cNvSpPr txBox="1"/>
+          <p:nvPr/>
+        </p:nvSpPr>
+        <p:spPr>
+          <a:xfrm>
+            <a:off x="365760" y="1298448"/>
+            <a:ext cx="2631186" cy="347472"/>
+          </a:xfrm>
+          <a:prstGeom prst="rect">
+            <a:avLst/>
+          </a:prstGeom>
+          <a:noFill/>
+        </p:spPr>
+        <p:txBody>
+          <a:bodyPr wrap="square">
+            <a:spAutoFit/>
+          </a:bodyPr>
+          <a:lstStyle/>
+          <a:p>
+            <a:pPr algn="ctr"/>
+            <a:r>
+              <a:rPr sz="850" b="0" i="0">
+                <a:solidFill>
+                  <a:srgbClr val="C8D6E5"/>
+                </a:solidFill>
+                <a:latin typeface="Calibri"/>
+              </a:rPr>
+              <a:t>All initiatives</a:t>
+            </a:r>
+          </a:p>
+        </p:txBody>
+      </p:sp>
+      <p:sp>
+        <p:nvSpPr>
+          <p:cNvPr id="12" name="Rectangle 11"/>
           <p:cNvSpPr/>
           <p:nvPr/>
         </p:nvSpPr>
         <p:spPr>
           <a:xfrm>
-            <a:off x="3225546" y="822960"/>
-            <a:ext cx="2786634" cy="50800"/>
+            <a:off x="3234690" y="859536"/>
+            <a:ext cx="2777490" cy="877824"/>
           </a:xfrm>
           <a:prstGeom prst="rect">
             <a:avLst/>
           </a:prstGeom>
           <a:solidFill>
-            <a:srgbClr val="F08C00"/>
+            <a:srgbClr val="1A65AC"/>
           </a:solidFill>
-          <a:ln w="9525">
+          <a:ln w="6350">
             <a:noFill/>
           </a:ln>
         </p:spPr>
@@ -3496,92 +3531,22 @@
       </p:sp>
       <p:sp>
         <p:nvSpPr>
-          <p:cNvPr id="12" name="TextBox 11"/>
-          <p:cNvSpPr txBox="1"/>
-          <p:nvPr/>
-        </p:nvSpPr>
-        <p:spPr>
-          <a:xfrm>
-            <a:off x="3316986" y="877824"/>
-            <a:ext cx="2603754" cy="384048"/>
-          </a:xfrm>
-          <a:prstGeom prst="rect">
-            <a:avLst/>
-          </a:prstGeom>
-          <a:noFill/>
-        </p:spPr>
-        <p:txBody>
-          <a:bodyPr wrap="square">
-            <a:spAutoFit/>
-          </a:bodyPr>
-          <a:lstStyle/>
-          <a:p>
-            <a:pPr algn="ctr"/>
-            <a:r>
-              <a:rPr sz="1250" b="1" i="0">
-                <a:solidFill>
-                  <a:srgbClr val="FFFFFF"/>
-                </a:solidFill>
-                <a:latin typeface="Calibri"/>
-              </a:rPr>
-              <a:t>No Additional Cost</a:t>
-            </a:r>
-          </a:p>
-        </p:txBody>
-      </p:sp>
-      <p:sp>
-        <p:nvSpPr>
-          <p:cNvPr id="13" name="TextBox 12"/>
-          <p:cNvSpPr txBox="1"/>
-          <p:nvPr/>
-        </p:nvSpPr>
-        <p:spPr>
-          <a:xfrm>
-            <a:off x="3298698" y="1243584"/>
-            <a:ext cx="2640330" cy="384048"/>
-          </a:xfrm>
-          <a:prstGeom prst="rect">
-            <a:avLst/>
-          </a:prstGeom>
-          <a:noFill/>
-        </p:spPr>
-        <p:txBody>
-          <a:bodyPr wrap="square">
-            <a:spAutoFit/>
-          </a:bodyPr>
-          <a:lstStyle/>
-          <a:p>
-            <a:pPr algn="ctr"/>
-            <a:r>
-              <a:rPr sz="850" b="0" i="0">
-                <a:solidFill>
-                  <a:srgbClr val="D0D8E4"/>
-                </a:solidFill>
-                <a:latin typeface="Calibri"/>
-              </a:rPr>
-              <a:t>Emergent work absorbed</a:t>
-            </a:r>
-          </a:p>
-        </p:txBody>
-      </p:sp>
-      <p:sp>
-        <p:nvSpPr>
-          <p:cNvPr id="14" name="Rectangle 13"/>
+          <p:cNvPr id="13" name="Rectangle 12"/>
           <p:cNvSpPr/>
           <p:nvPr/>
         </p:nvSpPr>
         <p:spPr>
           <a:xfrm>
-            <a:off x="6176772" y="822960"/>
-            <a:ext cx="2786634" cy="914400"/>
+            <a:off x="3234690" y="859536"/>
+            <a:ext cx="2777490" cy="63500"/>
           </a:xfrm>
           <a:prstGeom prst="rect">
             <a:avLst/>
           </a:prstGeom>
           <a:solidFill>
-            <a:srgbClr val="1A375E"/>
+            <a:srgbClr val="E8821A"/>
           </a:solidFill>
-          <a:ln w="9525">
+          <a:ln w="6350">
             <a:noFill/>
           </a:ln>
         </p:spPr>
@@ -3609,22 +3574,92 @@
       </p:sp>
       <p:sp>
         <p:nvSpPr>
-          <p:cNvPr id="15" name="Rectangle 14"/>
+          <p:cNvPr id="14" name="TextBox 13"/>
+          <p:cNvSpPr txBox="1"/>
+          <p:nvPr/>
+        </p:nvSpPr>
+        <p:spPr>
+          <a:xfrm>
+            <a:off x="3326130" y="923544"/>
+            <a:ext cx="2594610" cy="384048"/>
+          </a:xfrm>
+          <a:prstGeom prst="rect">
+            <a:avLst/>
+          </a:prstGeom>
+          <a:noFill/>
+        </p:spPr>
+        <p:txBody>
+          <a:bodyPr wrap="square">
+            <a:spAutoFit/>
+          </a:bodyPr>
+          <a:lstStyle/>
+          <a:p>
+            <a:pPr algn="ctr"/>
+            <a:r>
+              <a:rPr sz="1200" b="1" i="0">
+                <a:solidFill>
+                  <a:srgbClr val="FFFFFF"/>
+                </a:solidFill>
+                <a:latin typeface="Calibri"/>
+              </a:rPr>
+              <a:t>No Added Cost</a:t>
+            </a:r>
+          </a:p>
+        </p:txBody>
+      </p:sp>
+      <p:sp>
+        <p:nvSpPr>
+          <p:cNvPr id="15" name="TextBox 14"/>
+          <p:cNvSpPr txBox="1"/>
+          <p:nvPr/>
+        </p:nvSpPr>
+        <p:spPr>
+          <a:xfrm>
+            <a:off x="3307842" y="1298448"/>
+            <a:ext cx="2631186" cy="347472"/>
+          </a:xfrm>
+          <a:prstGeom prst="rect">
+            <a:avLst/>
+          </a:prstGeom>
+          <a:noFill/>
+        </p:spPr>
+        <p:txBody>
+          <a:bodyPr wrap="square">
+            <a:spAutoFit/>
+          </a:bodyPr>
+          <a:lstStyle/>
+          <a:p>
+            <a:pPr algn="ctr"/>
+            <a:r>
+              <a:rPr sz="850" b="0" i="0">
+                <a:solidFill>
+                  <a:srgbClr val="C8D6E5"/>
+                </a:solidFill>
+                <a:latin typeface="Calibri"/>
+              </a:rPr>
+              <a:t>Emergent work absorbed</a:t>
+            </a:r>
+          </a:p>
+        </p:txBody>
+      </p:sp>
+      <p:sp>
+        <p:nvSpPr>
+          <p:cNvPr id="16" name="Rectangle 15"/>
           <p:cNvSpPr/>
           <p:nvPr/>
         </p:nvSpPr>
         <p:spPr>
           <a:xfrm>
-            <a:off x="6176772" y="822960"/>
-            <a:ext cx="2786634" cy="50800"/>
+            <a:off x="6176772" y="859536"/>
+            <a:ext cx="2777490" cy="877824"/>
           </a:xfrm>
           <a:prstGeom prst="rect">
             <a:avLst/>
           </a:prstGeom>
           <a:solidFill>
-            <a:srgbClr val="F08C00"/>
+            <a:srgbClr val="1A65AC"/>
           </a:solidFill>
-          <a:ln w="9525">
+          <a:ln w="6350">
             <a:noFill/>
           </a:ln>
         </p:spPr>
@@ -3652,92 +3687,22 @@
       </p:sp>
       <p:sp>
         <p:nvSpPr>
-          <p:cNvPr id="16" name="TextBox 15"/>
-          <p:cNvSpPr txBox="1"/>
-          <p:nvPr/>
-        </p:nvSpPr>
-        <p:spPr>
-          <a:xfrm>
-            <a:off x="6268212" y="877824"/>
-            <a:ext cx="2603754" cy="384048"/>
-          </a:xfrm>
-          <a:prstGeom prst="rect">
-            <a:avLst/>
-          </a:prstGeom>
-          <a:noFill/>
-        </p:spPr>
-        <p:txBody>
-          <a:bodyPr wrap="square">
-            <a:spAutoFit/>
-          </a:bodyPr>
-          <a:lstStyle/>
-          <a:p>
-            <a:pPr algn="ctr"/>
-            <a:r>
-              <a:rPr sz="1250" b="1" i="0">
-                <a:solidFill>
-                  <a:srgbClr val="FFFFFF"/>
-                </a:solidFill>
-                <a:latin typeface="Calibri"/>
-              </a:rPr>
-              <a:t>Reg 5 KPIs</a:t>
-            </a:r>
-          </a:p>
-        </p:txBody>
-      </p:sp>
-      <p:sp>
-        <p:nvSpPr>
-          <p:cNvPr id="17" name="TextBox 16"/>
-          <p:cNvSpPr txBox="1"/>
-          <p:nvPr/>
-        </p:nvSpPr>
-        <p:spPr>
-          <a:xfrm>
-            <a:off x="6249924" y="1243584"/>
-            <a:ext cx="2640330" cy="384048"/>
-          </a:xfrm>
-          <a:prstGeom prst="rect">
-            <a:avLst/>
-          </a:prstGeom>
-          <a:noFill/>
-        </p:spPr>
-        <p:txBody>
-          <a:bodyPr wrap="square">
-            <a:spAutoFit/>
-          </a:bodyPr>
-          <a:lstStyle/>
-          <a:p>
-            <a:pPr algn="ctr"/>
-            <a:r>
-              <a:rPr sz="850" b="0" i="0">
-                <a:solidFill>
-                  <a:srgbClr val="D0D8E4"/>
-                </a:solidFill>
-                <a:latin typeface="Calibri"/>
-              </a:rPr>
-              <a:t>No observations</a:t>
-            </a:r>
-          </a:p>
-        </p:txBody>
-      </p:sp>
-      <p:sp>
-        <p:nvSpPr>
-          <p:cNvPr id="18" name="Rectangle 17"/>
+          <p:cNvPr id="17" name="Rectangle 16"/>
           <p:cNvSpPr/>
           <p:nvPr/>
         </p:nvSpPr>
         <p:spPr>
           <a:xfrm>
-            <a:off x="9127998" y="822960"/>
-            <a:ext cx="2786634" cy="914400"/>
+            <a:off x="6176772" y="859536"/>
+            <a:ext cx="2777490" cy="63500"/>
           </a:xfrm>
           <a:prstGeom prst="rect">
             <a:avLst/>
           </a:prstGeom>
           <a:solidFill>
-            <a:srgbClr val="1A375E"/>
+            <a:srgbClr val="3A9935"/>
           </a:solidFill>
-          <a:ln w="9525">
+          <a:ln w="6350">
             <a:noFill/>
           </a:ln>
         </p:spPr>
@@ -3765,22 +3730,92 @@
       </p:sp>
       <p:sp>
         <p:nvSpPr>
-          <p:cNvPr id="19" name="Rectangle 18"/>
+          <p:cNvPr id="18" name="TextBox 17"/>
+          <p:cNvSpPr txBox="1"/>
+          <p:nvPr/>
+        </p:nvSpPr>
+        <p:spPr>
+          <a:xfrm>
+            <a:off x="6268212" y="923544"/>
+            <a:ext cx="2594610" cy="384048"/>
+          </a:xfrm>
+          <a:prstGeom prst="rect">
+            <a:avLst/>
+          </a:prstGeom>
+          <a:noFill/>
+        </p:spPr>
+        <p:txBody>
+          <a:bodyPr wrap="square">
+            <a:spAutoFit/>
+          </a:bodyPr>
+          <a:lstStyle/>
+          <a:p>
+            <a:pPr algn="ctr"/>
+            <a:r>
+              <a:rPr sz="1200" b="1" i="0">
+                <a:solidFill>
+                  <a:srgbClr val="FFFFFF"/>
+                </a:solidFill>
+                <a:latin typeface="Calibri"/>
+              </a:rPr>
+              <a:t>Reg 5 KPIs</a:t>
+            </a:r>
+          </a:p>
+        </p:txBody>
+      </p:sp>
+      <p:sp>
+        <p:nvSpPr>
+          <p:cNvPr id="19" name="TextBox 18"/>
+          <p:cNvSpPr txBox="1"/>
+          <p:nvPr/>
+        </p:nvSpPr>
+        <p:spPr>
+          <a:xfrm>
+            <a:off x="6249924" y="1298448"/>
+            <a:ext cx="2631186" cy="347472"/>
+          </a:xfrm>
+          <a:prstGeom prst="rect">
+            <a:avLst/>
+          </a:prstGeom>
+          <a:noFill/>
+        </p:spPr>
+        <p:txBody>
+          <a:bodyPr wrap="square">
+            <a:spAutoFit/>
+          </a:bodyPr>
+          <a:lstStyle/>
+          <a:p>
+            <a:pPr algn="ctr"/>
+            <a:r>
+              <a:rPr sz="850" b="0" i="0">
+                <a:solidFill>
+                  <a:srgbClr val="C8D6E5"/>
+                </a:solidFill>
+                <a:latin typeface="Calibri"/>
+              </a:rPr>
+              <a:t>No observations raised</a:t>
+            </a:r>
+          </a:p>
+        </p:txBody>
+      </p:sp>
+      <p:sp>
+        <p:nvSpPr>
+          <p:cNvPr id="20" name="Rectangle 19"/>
           <p:cNvSpPr/>
           <p:nvPr/>
         </p:nvSpPr>
         <p:spPr>
           <a:xfrm>
-            <a:off x="9127998" y="822960"/>
-            <a:ext cx="2786634" cy="50800"/>
+            <a:off x="9118854" y="859536"/>
+            <a:ext cx="2777490" cy="877824"/>
           </a:xfrm>
           <a:prstGeom prst="rect">
             <a:avLst/>
           </a:prstGeom>
           <a:solidFill>
-            <a:srgbClr val="F08C00"/>
+            <a:srgbClr val="1A65AC"/>
           </a:solidFill>
-          <a:ln w="9525">
+          <a:ln w="6350">
             <a:noFill/>
           </a:ln>
         </p:spPr>
@@ -3808,14 +3843,57 @@
       </p:sp>
       <p:sp>
         <p:nvSpPr>
-          <p:cNvPr id="20" name="TextBox 19"/>
+          <p:cNvPr id="21" name="Rectangle 20"/>
+          <p:cNvSpPr/>
+          <p:nvPr/>
+        </p:nvSpPr>
+        <p:spPr>
+          <a:xfrm>
+            <a:off x="9118854" y="859536"/>
+            <a:ext cx="2777490" cy="63500"/>
+          </a:xfrm>
+          <a:prstGeom prst="rect">
+            <a:avLst/>
+          </a:prstGeom>
+          <a:solidFill>
+            <a:srgbClr val="E8821A"/>
+          </a:solidFill>
+          <a:ln w="6350">
+            <a:noFill/>
+          </a:ln>
+        </p:spPr>
+        <p:style>
+          <a:lnRef idx="1">
+            <a:schemeClr val="accent1"/>
+          </a:lnRef>
+          <a:fillRef idx="3">
+            <a:schemeClr val="accent1"/>
+          </a:fillRef>
+          <a:effectRef idx="2">
+            <a:schemeClr val="accent1"/>
+          </a:effectRef>
+          <a:fontRef idx="minor">
+            <a:schemeClr val="lt1"/>
+          </a:fontRef>
+        </p:style>
+        <p:txBody>
+          <a:bodyPr rtlCol="0" anchor="ctr"/>
+          <a:lstStyle/>
+          <a:p>
+            <a:pPr algn="ctr"/>
+          </a:p>
+        </p:txBody>
+      </p:sp>
+      <p:sp>
+        <p:nvSpPr>
+          <p:cNvPr id="22" name="TextBox 21"/>
           <p:cNvSpPr txBox="1"/>
           <p:nvPr/>
         </p:nvSpPr>
         <p:spPr>
           <a:xfrm>
-            <a:off x="9219438" y="877824"/>
-            <a:ext cx="2603754" cy="384048"/>
+            <a:off x="9210294" y="923544"/>
+            <a:ext cx="2594610" cy="384048"/>
           </a:xfrm>
           <a:prstGeom prst="rect">
             <a:avLst/>
@@ -3830,7 +3908,7 @@
           <a:p>
             <a:pPr algn="ctr"/>
             <a:r>
-              <a:rPr sz="1250" b="1" i="0">
+              <a:rPr sz="1200" b="1" i="0">
                 <a:solidFill>
                   <a:srgbClr val="FFFFFF"/>
                 </a:solidFill>
@@ -3843,14 +3921,14 @@
       </p:sp>
       <p:sp>
         <p:nvSpPr>
-          <p:cNvPr id="21" name="TextBox 20"/>
+          <p:cNvPr id="23" name="TextBox 22"/>
           <p:cNvSpPr txBox="1"/>
           <p:nvPr/>
         </p:nvSpPr>
         <p:spPr>
           <a:xfrm>
-            <a:off x="9201150" y="1243584"/>
-            <a:ext cx="2640330" cy="384048"/>
+            <a:off x="9192006" y="1298448"/>
+            <a:ext cx="2631186" cy="347472"/>
           </a:xfrm>
           <a:prstGeom prst="rect">
             <a:avLst/>
@@ -3867,7 +3945,7 @@
             <a:r>
               <a:rPr sz="850" b="0" i="0">
                 <a:solidFill>
-                  <a:srgbClr val="D0D8E4"/>
+                  <a:srgbClr val="C8D6E5"/>
                 </a:solidFill>
                 <a:latin typeface="Calibri"/>
               </a:rPr>
@@ -3878,14 +3956,14 @@
       </p:sp>
       <p:sp>
         <p:nvSpPr>
-          <p:cNvPr id="22" name="Rectangle 21"/>
+          <p:cNvPr id="24" name="Rectangle 23"/>
           <p:cNvSpPr/>
           <p:nvPr/>
         </p:nvSpPr>
         <p:spPr>
           <a:xfrm>
-            <a:off x="274320" y="1920240"/>
-            <a:ext cx="4251960" cy="3246120"/>
+            <a:off x="292608" y="1938528"/>
+            <a:ext cx="5742432" cy="3182112"/>
           </a:xfrm>
           <a:prstGeom prst="rect">
             <a:avLst/>
@@ -3895,7 +3973,7 @@
           </a:solidFill>
           <a:ln w="6350">
             <a:solidFill>
-              <a:srgbClr val="D0D8E4"/>
+              <a:srgbClr val="C8D6E5"/>
             </a:solidFill>
           </a:ln>
         </p:spPr>
@@ -3923,22 +4001,22 @@
       </p:sp>
       <p:sp>
         <p:nvSpPr>
-          <p:cNvPr id="23" name="Rectangle 22"/>
+          <p:cNvPr id="25" name="Rectangle 24"/>
           <p:cNvSpPr/>
           <p:nvPr/>
         </p:nvSpPr>
         <p:spPr>
           <a:xfrm>
-            <a:off x="274320" y="1920240"/>
-            <a:ext cx="4251960" cy="292608"/>
+            <a:off x="292608" y="1938528"/>
+            <a:ext cx="5742432" cy="301752"/>
           </a:xfrm>
           <a:prstGeom prst="rect">
             <a:avLst/>
           </a:prstGeom>
           <a:solidFill>
-            <a:srgbClr val="1F6FB2"/>
+            <a:srgbClr val="1A65AC"/>
           </a:solidFill>
-          <a:ln w="9525">
+          <a:ln w="6350">
             <a:noFill/>
           </a:ln>
         </p:spPr>
@@ -3966,14 +4044,57 @@
       </p:sp>
       <p:sp>
         <p:nvSpPr>
-          <p:cNvPr id="24" name="TextBox 23"/>
+          <p:cNvPr id="26" name="Rectangle 25"/>
+          <p:cNvSpPr/>
+          <p:nvPr/>
+        </p:nvSpPr>
+        <p:spPr>
+          <a:xfrm>
+            <a:off x="292608" y="1938528"/>
+            <a:ext cx="50800" cy="301752"/>
+          </a:xfrm>
+          <a:prstGeom prst="rect">
+            <a:avLst/>
+          </a:prstGeom>
+          <a:solidFill>
+            <a:srgbClr val="E8821A"/>
+          </a:solidFill>
+          <a:ln w="6350">
+            <a:noFill/>
+          </a:ln>
+        </p:spPr>
+        <p:style>
+          <a:lnRef idx="1">
+            <a:schemeClr val="accent1"/>
+          </a:lnRef>
+          <a:fillRef idx="3">
+            <a:schemeClr val="accent1"/>
+          </a:fillRef>
+          <a:effectRef idx="2">
+            <a:schemeClr val="accent1"/>
+          </a:effectRef>
+          <a:fontRef idx="minor">
+            <a:schemeClr val="lt1"/>
+          </a:fontRef>
+        </p:style>
+        <p:txBody>
+          <a:bodyPr rtlCol="0" anchor="ctr"/>
+          <a:lstStyle/>
+          <a:p>
+            <a:pPr algn="ctr"/>
+          </a:p>
+        </p:txBody>
+      </p:sp>
+      <p:sp>
+        <p:nvSpPr>
+          <p:cNvPr id="27" name="TextBox 26"/>
           <p:cNvSpPr txBox="1"/>
           <p:nvPr/>
         </p:nvSpPr>
         <p:spPr>
           <a:xfrm>
-            <a:off x="384048" y="1956816"/>
-            <a:ext cx="4032504" cy="237744"/>
+            <a:off x="438912" y="1979676"/>
+            <a:ext cx="5486400" cy="237744"/>
           </a:xfrm>
           <a:prstGeom prst="rect">
             <a:avLst/>
@@ -4001,14 +4122,14 @@
       </p:sp>
       <p:sp>
         <p:nvSpPr>
-          <p:cNvPr id="25" name="TextBox 24"/>
+          <p:cNvPr id="28" name="TextBox 27"/>
           <p:cNvSpPr txBox="1"/>
           <p:nvPr/>
         </p:nvSpPr>
         <p:spPr>
           <a:xfrm>
-            <a:off x="402336" y="2249424"/>
-            <a:ext cx="3995928" cy="2843784"/>
+            <a:off x="438912" y="2286000"/>
+            <a:ext cx="5449824" cy="2743200"/>
           </a:xfrm>
           <a:prstGeom prst="rect">
             <a:avLst/>
@@ -4020,6 +4141,84 @@
             <a:spAutoFit/>
           </a:bodyPr>
           <a:lstStyle/>
+          <a:p>
+            <a:pPr>
+              <a:spcBef>
+                <a:spcPts val="0"/>
+              </a:spcBef>
+              <a:buChar char="▪"/>
+            </a:pPr>
+            <a:r>
+              <a:rPr sz="900" b="1">
+                <a:solidFill>
+                  <a:srgbClr val="2B2B2B"/>
+                </a:solidFill>
+                <a:latin typeface="Calibri"/>
+              </a:rPr>
+              <a:t>KPI Dashboard:  </a:t>
+            </a:r>
+            <a:r>
+              <a:rPr sz="900" b="0">
+                <a:solidFill>
+                  <a:srgbClr val="219653"/>
+                </a:solidFill>
+                <a:latin typeface="Calibri"/>
+              </a:rPr>
+              <a:t>Centralisation &amp; AIRB complete; NEO Next rollout live; automation in progress.</a:t>
+            </a:r>
+          </a:p>
+          <a:p>
+            <a:pPr lvl="1">
+              <a:spcBef>
+                <a:spcPts val="300"/>
+              </a:spcBef>
+              <a:buChar char="○"/>
+            </a:pPr>
+            <a:r>
+              <a:rPr sz="900" b="1">
+                <a:solidFill>
+                  <a:srgbClr val="2B2B2B"/>
+                </a:solidFill>
+                <a:latin typeface="Calibri"/>
+              </a:rPr>
+              <a:t>Omega 365 — Incident Management:  </a:t>
+            </a:r>
+            <a:r>
+              <a:rPr sz="900" b="0">
+                <a:solidFill>
+                  <a:srgbClr val="219653"/>
+                </a:solidFill>
+                <a:latin typeface="Calibri"/>
+              </a:rPr>
+              <a:t>Live</a:t>
+            </a:r>
+          </a:p>
+          <a:p>
+            <a:pPr lvl="1">
+              <a:spcBef>
+                <a:spcPts val="300"/>
+              </a:spcBef>
+              <a:buChar char="○"/>
+            </a:pPr>
+            <a:r>
+              <a:rPr sz="900" b="1">
+                <a:solidFill>
+                  <a:srgbClr val="2B2B2B"/>
+                </a:solidFill>
+                <a:latin typeface="Calibri"/>
+              </a:rPr>
+              <a:t>Omega 365 — Action Management:  </a:t>
+            </a:r>
+            <a:r>
+              <a:rPr sz="900" b="0">
+                <a:solidFill>
+                  <a:srgbClr val="D45A00"/>
+                </a:solidFill>
+                <a:latin typeface="Calibri"/>
+              </a:rPr>
+              <a:t>Live  (Quality rollout delayed)</a:t>
+            </a:r>
+          </a:p>
           <a:p>
             <a:pPr>
               <a:spcBef>
@@ -4030,11 +4229,11 @@
             <a:r>
               <a:rPr sz="900" b="1">
                 <a:solidFill>
-                  <a:srgbClr val="1A375E"/>
-                </a:solidFill>
-                <a:latin typeface="Calibri"/>
-              </a:rPr>
-              <a:t>KPI Dashboard:  </a:t>
+                  <a:srgbClr val="2B2B2B"/>
+                </a:solidFill>
+                <a:latin typeface="Calibri"/>
+              </a:rPr>
+              <a:t>COSHH 365:  </a:t>
             </a:r>
             <a:r>
               <a:rPr sz="900" b="0">
@@ -4043,59 +4242,7 @@
                 </a:solidFill>
                 <a:latin typeface="Calibri"/>
               </a:rPr>
-              <a:t>Centralisation &amp; AIRB complete; NEO Next rollout live; automation in progress.</a:t>
-            </a:r>
-          </a:p>
-          <a:p>
-            <a:pPr lvl="1">
-              <a:spcBef>
-                <a:spcPts val="100"/>
-              </a:spcBef>
-              <a:buChar char="○"/>
-            </a:pPr>
-            <a:r>
-              <a:rPr sz="850" b="1">
-                <a:solidFill>
-                  <a:srgbClr val="1A375E"/>
-                </a:solidFill>
-                <a:latin typeface="Calibri"/>
-              </a:rPr>
-              <a:t>Omega 365 — Incident Management:  </a:t>
-            </a:r>
-            <a:r>
-              <a:rPr sz="850" b="0">
-                <a:solidFill>
-                  <a:srgbClr val="219653"/>
-                </a:solidFill>
-                <a:latin typeface="Calibri"/>
-              </a:rPr>
-              <a:t>Live</a:t>
-            </a:r>
-          </a:p>
-          <a:p>
-            <a:pPr lvl="1">
-              <a:spcBef>
-                <a:spcPts val="100"/>
-              </a:spcBef>
-              <a:buChar char="○"/>
-            </a:pPr>
-            <a:r>
-              <a:rPr sz="850" b="1">
-                <a:solidFill>
-                  <a:srgbClr val="1A375E"/>
-                </a:solidFill>
-                <a:latin typeface="Calibri"/>
-              </a:rPr>
-              <a:t>Omega 365 — Action Management:  </a:t>
-            </a:r>
-            <a:r>
-              <a:rPr sz="850" b="0">
-                <a:solidFill>
-                  <a:srgbClr val="E65C00"/>
-                </a:solidFill>
-                <a:latin typeface="Calibri"/>
-              </a:rPr>
-              <a:t>Live  (Quality rollout delayed)</a:t>
+              <a:t>Live; adoption gate approved</a:t>
             </a:r>
           </a:p>
           <a:p>
@@ -4108,20 +4255,20 @@
             <a:r>
               <a:rPr sz="900" b="1">
                 <a:solidFill>
-                  <a:srgbClr val="1A375E"/>
-                </a:solidFill>
-                <a:latin typeface="Calibri"/>
-              </a:rPr>
-              <a:t>COSHH 365:  </a:t>
+                  <a:srgbClr val="2B2B2B"/>
+                </a:solidFill>
+                <a:latin typeface="Calibri"/>
+              </a:rPr>
+              <a:t>Salus Suite:  </a:t>
             </a:r>
             <a:r>
               <a:rPr sz="900" b="0">
                 <a:solidFill>
-                  <a:srgbClr val="219653"/>
-                </a:solidFill>
-                <a:latin typeface="Calibri"/>
-              </a:rPr>
-              <a:t>Live; adoption gate approved</a:t>
+                  <a:srgbClr val="D45A00"/>
+                </a:solidFill>
+                <a:latin typeface="Calibri"/>
+              </a:rPr>
+              <a:t>In progress; delayed by Safety Case priorities; training commenced</a:t>
             </a:r>
           </a:p>
           <a:p>
@@ -4134,20 +4281,20 @@
             <a:r>
               <a:rPr sz="900" b="1">
                 <a:solidFill>
-                  <a:srgbClr val="1A375E"/>
-                </a:solidFill>
-                <a:latin typeface="Calibri"/>
-              </a:rPr>
-              <a:t>Salus Suite:  </a:t>
+                  <a:srgbClr val="2B2B2B"/>
+                </a:solidFill>
+                <a:latin typeface="Calibri"/>
+              </a:rPr>
+              <a:t>BP Andrew &amp; NEO Transition:  </a:t>
             </a:r>
             <a:r>
               <a:rPr sz="900" b="0">
                 <a:solidFill>
-                  <a:srgbClr val="E65C00"/>
-                </a:solidFill>
-                <a:latin typeface="Calibri"/>
-              </a:rPr>
-              <a:t>In progress; delayed by Safety Case priorities; training commenced</a:t>
+                  <a:srgbClr val="219653"/>
+                </a:solidFill>
+                <a:latin typeface="Calibri"/>
+              </a:rPr>
+              <a:t>Active</a:t>
             </a:r>
           </a:p>
           <a:p>
@@ -4160,11 +4307,11 @@
             <a:r>
               <a:rPr sz="900" b="1">
                 <a:solidFill>
-                  <a:srgbClr val="1A375E"/>
-                </a:solidFill>
-                <a:latin typeface="Calibri"/>
-              </a:rPr>
-              <a:t>BP Andrew &amp; NEO Transition Support:  </a:t>
+                  <a:srgbClr val="2B2B2B"/>
+                </a:solidFill>
+                <a:latin typeface="Calibri"/>
+              </a:rPr>
+              <a:t>Reg 5 Support:  </a:t>
             </a:r>
             <a:r>
               <a:rPr sz="900" b="0">
@@ -4186,20 +4333,20 @@
             <a:r>
               <a:rPr sz="900" b="1">
                 <a:solidFill>
-                  <a:srgbClr val="1A375E"/>
-                </a:solidFill>
-                <a:latin typeface="Calibri"/>
-              </a:rPr>
-              <a:t>Reg 5 Support:  </a:t>
+                  <a:srgbClr val="2B2B2B"/>
+                </a:solidFill>
+                <a:latin typeface="Calibri"/>
+              </a:rPr>
+              <a:t>Training &amp; Competence:  </a:t>
             </a:r>
             <a:r>
               <a:rPr sz="900" b="0">
                 <a:solidFill>
-                  <a:srgbClr val="219653"/>
-                </a:solidFill>
-                <a:latin typeface="Calibri"/>
-              </a:rPr>
-              <a:t>Active</a:t>
+                  <a:srgbClr val="D45A00"/>
+                </a:solidFill>
+                <a:latin typeface="Calibri"/>
+              </a:rPr>
+              <a:t>Vendor selection in progress</a:t>
             </a:r>
           </a:p>
           <a:p>
@@ -4212,42 +4359,16 @@
             <a:r>
               <a:rPr sz="900" b="1">
                 <a:solidFill>
-                  <a:srgbClr val="1A375E"/>
-                </a:solidFill>
-                <a:latin typeface="Calibri"/>
-              </a:rPr>
-              <a:t>Training &amp; Competence:  </a:t>
+                  <a:srgbClr val="2B2B2B"/>
+                </a:solidFill>
+                <a:latin typeface="Calibri"/>
+              </a:rPr>
+              <a:t>CMMS:  </a:t>
             </a:r>
             <a:r>
               <a:rPr sz="900" b="0">
                 <a:solidFill>
-                  <a:srgbClr val="E65C00"/>
-                </a:solidFill>
-                <a:latin typeface="Calibri"/>
-              </a:rPr>
-              <a:t>Vendor selection in progress</a:t>
-            </a:r>
-          </a:p>
-          <a:p>
-            <a:pPr>
-              <a:spcBef>
-                <a:spcPts val="300"/>
-              </a:spcBef>
-              <a:buChar char="▪"/>
-            </a:pPr>
-            <a:r>
-              <a:rPr sz="900" b="1">
-                <a:solidFill>
-                  <a:srgbClr val="1A375E"/>
-                </a:solidFill>
-                <a:latin typeface="Calibri"/>
-              </a:rPr>
-              <a:t>CMMS:  </a:t>
-            </a:r>
-            <a:r>
-              <a:rPr sz="900" b="0">
-                <a:solidFill>
-                  <a:srgbClr val="E65C00"/>
+                  <a:srgbClr val="D45A00"/>
                 </a:solidFill>
                 <a:latin typeface="Calibri"/>
               </a:rPr>
@@ -4258,14 +4379,14 @@
       </p:sp>
       <p:sp>
         <p:nvSpPr>
-          <p:cNvPr id="26" name="Rectangle 25"/>
+          <p:cNvPr id="29" name="Rectangle 28"/>
           <p:cNvSpPr/>
           <p:nvPr/>
         </p:nvSpPr>
         <p:spPr>
           <a:xfrm>
-            <a:off x="7187184" y="1920240"/>
-            <a:ext cx="4251960" cy="3246120"/>
+            <a:off x="6199632" y="1938528"/>
+            <a:ext cx="5742432" cy="3182112"/>
           </a:xfrm>
           <a:prstGeom prst="rect">
             <a:avLst/>
@@ -4275,7 +4396,7 @@
           </a:solidFill>
           <a:ln w="6350">
             <a:solidFill>
-              <a:srgbClr val="D0D8E4"/>
+              <a:srgbClr val="C8D6E5"/>
             </a:solidFill>
           </a:ln>
         </p:spPr>
@@ -4303,22 +4424,22 @@
       </p:sp>
       <p:sp>
         <p:nvSpPr>
-          <p:cNvPr id="27" name="Rectangle 26"/>
+          <p:cNvPr id="30" name="Rectangle 29"/>
           <p:cNvSpPr/>
           <p:nvPr/>
         </p:nvSpPr>
         <p:spPr>
           <a:xfrm>
-            <a:off x="7187184" y="1920240"/>
-            <a:ext cx="4251960" cy="292608"/>
+            <a:off x="6199632" y="1938528"/>
+            <a:ext cx="5742432" cy="301752"/>
           </a:xfrm>
           <a:prstGeom prst="rect">
             <a:avLst/>
           </a:prstGeom>
           <a:solidFill>
-            <a:srgbClr val="1F6FB2"/>
+            <a:srgbClr val="1A65AC"/>
           </a:solidFill>
-          <a:ln w="9525">
+          <a:ln w="6350">
             <a:noFill/>
           </a:ln>
         </p:spPr>
@@ -4346,14 +4467,57 @@
       </p:sp>
       <p:sp>
         <p:nvSpPr>
-          <p:cNvPr id="28" name="TextBox 27"/>
+          <p:cNvPr id="31" name="Rectangle 30"/>
+          <p:cNvSpPr/>
+          <p:nvPr/>
+        </p:nvSpPr>
+        <p:spPr>
+          <a:xfrm>
+            <a:off x="6199632" y="1938528"/>
+            <a:ext cx="50800" cy="301752"/>
+          </a:xfrm>
+          <a:prstGeom prst="rect">
+            <a:avLst/>
+          </a:prstGeom>
+          <a:solidFill>
+            <a:srgbClr val="E8821A"/>
+          </a:solidFill>
+          <a:ln w="6350">
+            <a:noFill/>
+          </a:ln>
+        </p:spPr>
+        <p:style>
+          <a:lnRef idx="1">
+            <a:schemeClr val="accent1"/>
+          </a:lnRef>
+          <a:fillRef idx="3">
+            <a:schemeClr val="accent1"/>
+          </a:fillRef>
+          <a:effectRef idx="2">
+            <a:schemeClr val="accent1"/>
+          </a:effectRef>
+          <a:fontRef idx="minor">
+            <a:schemeClr val="lt1"/>
+          </a:fontRef>
+        </p:style>
+        <p:txBody>
+          <a:bodyPr rtlCol="0" anchor="ctr"/>
+          <a:lstStyle/>
+          <a:p>
+            <a:pPr algn="ctr"/>
+          </a:p>
+        </p:txBody>
+      </p:sp>
+      <p:sp>
+        <p:nvSpPr>
+          <p:cNvPr id="32" name="TextBox 31"/>
           <p:cNvSpPr txBox="1"/>
           <p:nvPr/>
         </p:nvSpPr>
         <p:spPr>
           <a:xfrm>
-            <a:off x="7296912" y="1956816"/>
-            <a:ext cx="4032504" cy="237744"/>
+            <a:off x="6345936" y="1979676"/>
+            <a:ext cx="5486400" cy="237744"/>
           </a:xfrm>
           <a:prstGeom prst="rect">
             <a:avLst/>
@@ -4381,14 +4545,14 @@
       </p:sp>
       <p:sp>
         <p:nvSpPr>
-          <p:cNvPr id="29" name="TextBox 28"/>
+          <p:cNvPr id="33" name="TextBox 32"/>
           <p:cNvSpPr txBox="1"/>
           <p:nvPr/>
         </p:nvSpPr>
         <p:spPr>
           <a:xfrm>
-            <a:off x="7315200" y="2249424"/>
-            <a:ext cx="3995928" cy="2843784"/>
+            <a:off x="6345936" y="2286000"/>
+            <a:ext cx="5449824" cy="2743200"/>
           </a:xfrm>
           <a:prstGeom prst="rect">
             <a:avLst/>
@@ -4405,11 +4569,12 @@
               <a:spcBef>
                 <a:spcPts val="0"/>
               </a:spcBef>
+              <a:buNone/>
             </a:pPr>
             <a:r>
               <a:rPr sz="900" b="1">
                 <a:solidFill>
-                  <a:srgbClr val="1F6FB2"/>
+                  <a:srgbClr val="1A65AC"/>
                 </a:solidFill>
                 <a:latin typeface="Calibri"/>
               </a:rPr>
@@ -4426,7 +4591,7 @@
             <a:r>
               <a:rPr sz="900" b="1">
                 <a:solidFill>
-                  <a:srgbClr val="1A375E"/>
+                  <a:srgbClr val="2B2B2B"/>
                 </a:solidFill>
                 <a:latin typeface="Calibri"/>
               </a:rPr>
@@ -4452,7 +4617,7 @@
             <a:r>
               <a:rPr sz="900" b="1">
                 <a:solidFill>
-                  <a:srgbClr val="1A375E"/>
+                  <a:srgbClr val="2B2B2B"/>
                 </a:solidFill>
                 <a:latin typeface="Calibri"/>
               </a:rPr>
@@ -4478,7 +4643,7 @@
             <a:r>
               <a:rPr sz="900" b="1">
                 <a:solidFill>
-                  <a:srgbClr val="1A375E"/>
+                  <a:srgbClr val="2B2B2B"/>
                 </a:solidFill>
                 <a:latin typeface="Calibri"/>
               </a:rPr>
@@ -4504,7 +4669,7 @@
             <a:r>
               <a:rPr sz="900" b="1">
                 <a:solidFill>
-                  <a:srgbClr val="1A375E"/>
+                  <a:srgbClr val="2B2B2B"/>
                 </a:solidFill>
                 <a:latin typeface="Calibri"/>
               </a:rPr>
@@ -4530,7 +4695,7 @@
             <a:r>
               <a:rPr sz="900" b="1">
                 <a:solidFill>
-                  <a:srgbClr val="1A375E"/>
+                  <a:srgbClr val="2B2B2B"/>
                 </a:solidFill>
                 <a:latin typeface="Calibri"/>
               </a:rPr>
@@ -4551,11 +4716,12 @@
               <a:spcBef>
                 <a:spcPts val="500"/>
               </a:spcBef>
+              <a:buNone/>
             </a:pPr>
             <a:r>
               <a:rPr sz="900" b="1">
                 <a:solidFill>
-                  <a:srgbClr val="1F6FB2"/>
+                  <a:srgbClr val="1A65AC"/>
                 </a:solidFill>
                 <a:latin typeface="Calibri"/>
               </a:rPr>
@@ -4572,7 +4738,7 @@
             <a:r>
               <a:rPr sz="900" b="1">
                 <a:solidFill>
-                  <a:srgbClr val="1A375E"/>
+                  <a:srgbClr val="2B2B2B"/>
                 </a:solidFill>
                 <a:latin typeface="Calibri"/>
               </a:rPr>
@@ -4581,7 +4747,7 @@
             <a:r>
               <a:rPr sz="900" b="0">
                 <a:solidFill>
-                  <a:srgbClr val="E65C00"/>
+                  <a:srgbClr val="D45A00"/>
                 </a:solidFill>
                 <a:latin typeface="Calibri"/>
               </a:rPr>
@@ -4598,7 +4764,7 @@
             <a:r>
               <a:rPr sz="900" b="1">
                 <a:solidFill>
-                  <a:srgbClr val="1A375E"/>
+                  <a:srgbClr val="2B2B2B"/>
                 </a:solidFill>
                 <a:latin typeface="Calibri"/>
               </a:rPr>
@@ -4607,7 +4773,7 @@
             <a:r>
               <a:rPr sz="900" b="0">
                 <a:solidFill>
-                  <a:srgbClr val="E65C00"/>
+                  <a:srgbClr val="D45A00"/>
                 </a:solidFill>
                 <a:latin typeface="Calibri"/>
               </a:rPr>
@@ -4624,7 +4790,7 @@
             <a:r>
               <a:rPr sz="900" b="1">
                 <a:solidFill>
-                  <a:srgbClr val="1A375E"/>
+                  <a:srgbClr val="2B2B2B"/>
                 </a:solidFill>
                 <a:latin typeface="Calibri"/>
               </a:rPr>
@@ -4633,7 +4799,7 @@
             <a:r>
               <a:rPr sz="900" b="0">
                 <a:solidFill>
-                  <a:srgbClr val="E65C00"/>
+                  <a:srgbClr val="D45A00"/>
                 </a:solidFill>
                 <a:latin typeface="Calibri"/>
               </a:rPr>
@@ -4645,11 +4811,12 @@
               <a:spcBef>
                 <a:spcPts val="500"/>
               </a:spcBef>
+              <a:buNone/>
             </a:pPr>
             <a:r>
               <a:rPr sz="900" b="1">
                 <a:solidFill>
-                  <a:srgbClr val="1F6FB2"/>
+                  <a:srgbClr val="1A65AC"/>
                 </a:solidFill>
                 <a:latin typeface="Calibri"/>
               </a:rPr>
@@ -4666,7 +4833,7 @@
             <a:r>
               <a:rPr sz="900" b="0">
                 <a:solidFill>
-                  <a:srgbClr val="1A375E"/>
+                  <a:srgbClr val="2B2B2B"/>
                 </a:solidFill>
                 <a:latin typeface="Calibri"/>
               </a:rPr>
@@ -4683,7 +4850,7 @@
             <a:r>
               <a:rPr sz="900" b="0">
                 <a:solidFill>
-                  <a:srgbClr val="1A375E"/>
+                  <a:srgbClr val="2B2B2B"/>
                 </a:solidFill>
                 <a:latin typeface="Calibri"/>
               </a:rPr>
@@ -4700,7 +4867,7 @@
             <a:r>
               <a:rPr sz="900" b="0">
                 <a:solidFill>
-                  <a:srgbClr val="1A375E"/>
+                  <a:srgbClr val="2B2B2B"/>
                 </a:solidFill>
                 <a:latin typeface="Calibri"/>
               </a:rPr>
@@ -4711,14 +4878,14 @@
       </p:sp>
       <p:sp>
         <p:nvSpPr>
-          <p:cNvPr id="30" name="Rectangle 29"/>
+          <p:cNvPr id="34" name="Rectangle 33"/>
           <p:cNvSpPr/>
           <p:nvPr/>
         </p:nvSpPr>
         <p:spPr>
           <a:xfrm>
-            <a:off x="274320" y="5303520"/>
-            <a:ext cx="11640312" cy="1170432"/>
+            <a:off x="292608" y="5266944"/>
+            <a:ext cx="11603736" cy="1188720"/>
           </a:xfrm>
           <a:prstGeom prst="rect">
             <a:avLst/>
@@ -4728,7 +4895,7 @@
           </a:solidFill>
           <a:ln w="6350">
             <a:solidFill>
-              <a:srgbClr val="D0D8E4"/>
+              <a:srgbClr val="C8D6E5"/>
             </a:solidFill>
           </a:ln>
         </p:spPr>
@@ -4756,22 +4923,22 @@
       </p:sp>
       <p:sp>
         <p:nvSpPr>
-          <p:cNvPr id="31" name="Rectangle 30"/>
+          <p:cNvPr id="35" name="Rectangle 34"/>
           <p:cNvSpPr/>
           <p:nvPr/>
         </p:nvSpPr>
         <p:spPr>
           <a:xfrm>
-            <a:off x="274320" y="5303520"/>
-            <a:ext cx="11640312" cy="292608"/>
+            <a:off x="292608" y="5266944"/>
+            <a:ext cx="11603736" cy="301752"/>
           </a:xfrm>
           <a:prstGeom prst="rect">
             <a:avLst/>
           </a:prstGeom>
           <a:solidFill>
-            <a:srgbClr val="F08C00"/>
+            <a:srgbClr val="3D3D3D"/>
           </a:solidFill>
-          <a:ln w="9525">
+          <a:ln w="6350">
             <a:noFill/>
           </a:ln>
         </p:spPr>
@@ -4799,14 +4966,57 @@
       </p:sp>
       <p:sp>
         <p:nvSpPr>
-          <p:cNvPr id="32" name="TextBox 31"/>
+          <p:cNvPr id="36" name="Rectangle 35"/>
+          <p:cNvSpPr/>
+          <p:nvPr/>
+        </p:nvSpPr>
+        <p:spPr>
+          <a:xfrm>
+            <a:off x="292608" y="5266944"/>
+            <a:ext cx="50800" cy="301752"/>
+          </a:xfrm>
+          <a:prstGeom prst="rect">
+            <a:avLst/>
+          </a:prstGeom>
+          <a:solidFill>
+            <a:srgbClr val="E8821A"/>
+          </a:solidFill>
+          <a:ln w="6350">
+            <a:noFill/>
+          </a:ln>
+        </p:spPr>
+        <p:style>
+          <a:lnRef idx="1">
+            <a:schemeClr val="accent1"/>
+          </a:lnRef>
+          <a:fillRef idx="3">
+            <a:schemeClr val="accent1"/>
+          </a:fillRef>
+          <a:effectRef idx="2">
+            <a:schemeClr val="accent1"/>
+          </a:effectRef>
+          <a:fontRef idx="minor">
+            <a:schemeClr val="lt1"/>
+          </a:fontRef>
+        </p:style>
+        <p:txBody>
+          <a:bodyPr rtlCol="0" anchor="ctr"/>
+          <a:lstStyle/>
+          <a:p>
+            <a:pPr algn="ctr"/>
+          </a:p>
+        </p:txBody>
+      </p:sp>
+      <p:sp>
+        <p:nvSpPr>
+          <p:cNvPr id="37" name="TextBox 36"/>
           <p:cNvSpPr txBox="1"/>
           <p:nvPr/>
         </p:nvSpPr>
         <p:spPr>
           <a:xfrm>
-            <a:off x="384048" y="5340096"/>
-            <a:ext cx="11420856" cy="237744"/>
+            <a:off x="438912" y="5308092"/>
+            <a:ext cx="11347704" cy="237744"/>
           </a:xfrm>
           <a:prstGeom prst="rect">
             <a:avLst/>
@@ -4834,14 +5044,57 @@
       </p:sp>
       <p:sp>
         <p:nvSpPr>
-          <p:cNvPr id="33" name="TextBox 32"/>
+          <p:cNvPr id="38" name="Rectangle 37"/>
+          <p:cNvSpPr/>
+          <p:nvPr/>
+        </p:nvSpPr>
+        <p:spPr>
+          <a:xfrm>
+            <a:off x="292608" y="5266944"/>
+            <a:ext cx="50800" cy="301752"/>
+          </a:xfrm>
+          <a:prstGeom prst="rect">
+            <a:avLst/>
+          </a:prstGeom>
+          <a:solidFill>
+            <a:srgbClr val="E8821A"/>
+          </a:solidFill>
+          <a:ln w="6350">
+            <a:noFill/>
+          </a:ln>
+        </p:spPr>
+        <p:style>
+          <a:lnRef idx="1">
+            <a:schemeClr val="accent1"/>
+          </a:lnRef>
+          <a:fillRef idx="3">
+            <a:schemeClr val="accent1"/>
+          </a:fillRef>
+          <a:effectRef idx="2">
+            <a:schemeClr val="accent1"/>
+          </a:effectRef>
+          <a:fontRef idx="minor">
+            <a:schemeClr val="lt1"/>
+          </a:fontRef>
+        </p:style>
+        <p:txBody>
+          <a:bodyPr rtlCol="0" anchor="ctr"/>
+          <a:lstStyle/>
+          <a:p>
+            <a:pPr algn="ctr"/>
+          </a:p>
+        </p:txBody>
+      </p:sp>
+      <p:sp>
+        <p:nvSpPr>
+          <p:cNvPr id="39" name="TextBox 38"/>
           <p:cNvSpPr txBox="1"/>
           <p:nvPr/>
         </p:nvSpPr>
         <p:spPr>
           <a:xfrm>
-            <a:off x="402336" y="5632704"/>
-            <a:ext cx="5692140" cy="768096"/>
+            <a:off x="438912" y="5614416"/>
+            <a:ext cx="5573268" cy="768096"/>
           </a:xfrm>
           <a:prstGeom prst="rect">
             <a:avLst/>
@@ -4863,7 +5116,7 @@
             <a:r>
               <a:rPr sz="950" b="0">
                 <a:solidFill>
-                  <a:srgbClr val="1A375E"/>
+                  <a:srgbClr val="2B2B2B"/>
                 </a:solidFill>
                 <a:latin typeface="Calibri"/>
               </a:rPr>
@@ -4880,7 +5133,7 @@
             <a:r>
               <a:rPr sz="950" b="0">
                 <a:solidFill>
-                  <a:srgbClr val="1A375E"/>
+                  <a:srgbClr val="2B2B2B"/>
                 </a:solidFill>
                 <a:latin typeface="Calibri"/>
               </a:rPr>
@@ -4897,7 +5150,7 @@
             <a:r>
               <a:rPr sz="950" b="0">
                 <a:solidFill>
-                  <a:srgbClr val="1A375E"/>
+                  <a:srgbClr val="2B2B2B"/>
                 </a:solidFill>
                 <a:latin typeface="Calibri"/>
               </a:rPr>
@@ -4908,14 +5161,14 @@
       </p:sp>
       <p:sp>
         <p:nvSpPr>
-          <p:cNvPr id="34" name="TextBox 33"/>
+          <p:cNvPr id="40" name="TextBox 39"/>
           <p:cNvSpPr txBox="1"/>
           <p:nvPr/>
         </p:nvSpPr>
         <p:spPr>
           <a:xfrm>
-            <a:off x="6185916" y="5632704"/>
-            <a:ext cx="5692140" cy="768096"/>
+            <a:off x="6176772" y="5614416"/>
+            <a:ext cx="5573268" cy="768096"/>
           </a:xfrm>
           <a:prstGeom prst="rect">
             <a:avLst/>
@@ -4937,7 +5190,7 @@
             <a:r>
               <a:rPr sz="950" b="0">
                 <a:solidFill>
-                  <a:srgbClr val="1A375E"/>
+                  <a:srgbClr val="2B2B2B"/>
                 </a:solidFill>
                 <a:latin typeface="Calibri"/>
               </a:rPr>
@@ -4954,7 +5207,7 @@
             <a:r>
               <a:rPr sz="950" b="0">
                 <a:solidFill>
-                  <a:srgbClr val="1A375E"/>
+                  <a:srgbClr val="2B2B2B"/>
                 </a:solidFill>
                 <a:latin typeface="Calibri"/>
               </a:rPr>
@@ -4971,7 +5224,7 @@
             <a:r>
               <a:rPr sz="950" b="0">
                 <a:solidFill>
-                  <a:srgbClr val="1A375E"/>
+                  <a:srgbClr val="2B2B2B"/>
                 </a:solidFill>
                 <a:latin typeface="Calibri"/>
               </a:rPr>
@@ -4982,7 +5235,7 @@
       </p:sp>
       <p:sp>
         <p:nvSpPr>
-          <p:cNvPr id="35" name="Rectangle 34"/>
+          <p:cNvPr id="41" name="Rectangle 40"/>
           <p:cNvSpPr/>
           <p:nvPr/>
         </p:nvSpPr>
@@ -4995,9 +5248,9 @@
             <a:avLst/>
           </a:prstGeom>
           <a:solidFill>
-            <a:srgbClr val="1A375E"/>
+            <a:srgbClr val="3D3D3D"/>
           </a:solidFill>
-          <a:ln w="9525">
+          <a:ln w="6350">
             <a:noFill/>
           </a:ln>
         </p:spPr>
@@ -5025,13 +5278,99 @@
       </p:sp>
       <p:sp>
         <p:nvSpPr>
-          <p:cNvPr id="36" name="TextBox 35"/>
+          <p:cNvPr id="42" name="Rectangle 41"/>
+          <p:cNvSpPr/>
+          <p:nvPr/>
+        </p:nvSpPr>
+        <p:spPr>
+          <a:xfrm>
+            <a:off x="0" y="6601968"/>
+            <a:ext cx="2194560" cy="38100"/>
+          </a:xfrm>
+          <a:prstGeom prst="rect">
+            <a:avLst/>
+          </a:prstGeom>
+          <a:solidFill>
+            <a:srgbClr val="3A9935"/>
+          </a:solidFill>
+          <a:ln w="6350">
+            <a:noFill/>
+          </a:ln>
+        </p:spPr>
+        <p:style>
+          <a:lnRef idx="1">
+            <a:schemeClr val="accent1"/>
+          </a:lnRef>
+          <a:fillRef idx="3">
+            <a:schemeClr val="accent1"/>
+          </a:fillRef>
+          <a:effectRef idx="2">
+            <a:schemeClr val="accent1"/>
+          </a:effectRef>
+          <a:fontRef idx="minor">
+            <a:schemeClr val="lt1"/>
+          </a:fontRef>
+        </p:style>
+        <p:txBody>
+          <a:bodyPr rtlCol="0" anchor="ctr"/>
+          <a:lstStyle/>
+          <a:p>
+            <a:pPr algn="ctr"/>
+          </a:p>
+        </p:txBody>
+      </p:sp>
+      <p:sp>
+        <p:nvSpPr>
+          <p:cNvPr id="43" name="Rectangle 42"/>
+          <p:cNvSpPr/>
+          <p:nvPr/>
+        </p:nvSpPr>
+        <p:spPr>
+          <a:xfrm>
+            <a:off x="2194560" y="6601968"/>
+            <a:ext cx="1097280" cy="38100"/>
+          </a:xfrm>
+          <a:prstGeom prst="rect">
+            <a:avLst/>
+          </a:prstGeom>
+          <a:solidFill>
+            <a:srgbClr val="E8821A"/>
+          </a:solidFill>
+          <a:ln w="6350">
+            <a:noFill/>
+          </a:ln>
+        </p:spPr>
+        <p:style>
+          <a:lnRef idx="1">
+            <a:schemeClr val="accent1"/>
+          </a:lnRef>
+          <a:fillRef idx="3">
+            <a:schemeClr val="accent1"/>
+          </a:fillRef>
+          <a:effectRef idx="2">
+            <a:schemeClr val="accent1"/>
+          </a:effectRef>
+          <a:fontRef idx="minor">
+            <a:schemeClr val="lt1"/>
+          </a:fontRef>
+        </p:style>
+        <p:txBody>
+          <a:bodyPr rtlCol="0" anchor="ctr"/>
+          <a:lstStyle/>
+          <a:p>
+            <a:pPr algn="ctr"/>
+          </a:p>
+        </p:txBody>
+      </p:sp>
+      <p:sp>
+        <p:nvSpPr>
+          <p:cNvPr id="44" name="TextBox 43"/>
           <p:cNvSpPr txBox="1"/>
           <p:nvPr/>
         </p:nvSpPr>
         <p:spPr>
           <a:xfrm>
-            <a:off x="274320" y="6638544"/>
+            <a:off x="292608" y="6638544"/>
             <a:ext cx="6094476" cy="201168"/>
           </a:xfrm>
           <a:prstGeom prst="rect">
@@ -5049,25 +5388,25 @@
             <a:r>
               <a:rPr sz="750" b="0" i="0">
                 <a:solidFill>
-                  <a:srgbClr val="D0D8E4"/>
-                </a:solidFill>
-                <a:latin typeface="Calibri"/>
-              </a:rPr>
-              <a:t>Strateq Digital  |  Confidential  |  June 2026</a:t>
-            </a:r>
-          </a:p>
-        </p:txBody>
-      </p:sp>
-      <p:sp>
-        <p:nvSpPr>
-          <p:cNvPr id="37" name="TextBox 36"/>
+                  <a:srgbClr val="A0B4C8"/>
+                </a:solidFill>
+                <a:latin typeface="Calibri"/>
+              </a:rPr>
+              <a:t>Thre360 Energy  |  Confidential  |  June 2026</a:t>
+            </a:r>
+          </a:p>
+        </p:txBody>
+      </p:sp>
+      <p:sp>
+        <p:nvSpPr>
+          <p:cNvPr id="45" name="TextBox 44"/>
           <p:cNvSpPr txBox="1"/>
           <p:nvPr/>
         </p:nvSpPr>
         <p:spPr>
           <a:xfrm>
             <a:off x="6094476" y="6638544"/>
-            <a:ext cx="5820156" cy="201168"/>
+            <a:ext cx="5801868" cy="201168"/>
           </a:xfrm>
           <a:prstGeom prst="rect">
             <a:avLst/>
@@ -5084,7 +5423,7 @@
             <a:r>
               <a:rPr sz="750" b="0" i="0">
                 <a:solidFill>
-                  <a:srgbClr val="D0D8E4"/>
+                  <a:srgbClr val="A0B4C8"/>
                 </a:solidFill>
                 <a:latin typeface="Calibri"/>
               </a:rPr>

</xml_diff>